<commit_message>
Polish the original deck's layout
Adds side margins, rebalances table columns, raises table text to 11pt,
evens out bullets, gives each table slide its own title, fills empty
Fix cells, and adds a color key to every slide.

Co-Authored-By: Claude Opus 5.5 <noreply@anthropic.com>
Claude-Session: https://claude.ai/code/session_01Wqdacbu9CA6sisd7FemKfK
</commit_message>
<xml_diff>
--- a/Leaky_Bucket.pptx
+++ b/Leaky_Bucket.pptx
@@ -17041,6 +17041,328 @@
           </a:p>
         </p:txBody>
       </p:sp>
+      <p:sp>
+        <p:nvSpPr>
+          <p:cNvPr id="9" name="Legend 9"/>
+          <p:cNvSpPr txBox="1"/>
+          <p:nvPr/>
+        </p:nvSpPr>
+        <p:spPr>
+          <a:xfrm>
+            <a:off x="304800" y="6250000"/>
+            <a:ext cx="1300000" cy="228600"/>
+          </a:xfrm>
+          <a:prstGeom prst="rect">
+            <a:avLst/>
+          </a:prstGeom>
+          <a:noFill/>
+          <a:ln>
+            <a:noFill/>
+          </a:ln>
+        </p:spPr>
+        <p:txBody>
+          <a:bodyPr wrap="none" lIns="0" tIns="0" rIns="0" bIns="0" anchor="ctr"/>
+          <a:lstStyle/>
+          <a:p>
+            <a:r>
+              <a:rPr lang="en-US" sz="1100" b="1">
+                <a:solidFill>
+                  <a:srgbClr val="404040"/>
+                </a:solidFill>
+              </a:rPr>
+              <a:t>Color key:</a:t>
+            </a:r>
+          </a:p>
+        </p:txBody>
+      </p:sp>
+      <p:sp>
+        <p:nvSpPr>
+          <p:cNvPr id="10" name="Legend 10"/>
+          <p:cNvSpPr txBox="0"/>
+          <p:nvPr/>
+        </p:nvSpPr>
+        <p:spPr>
+          <a:xfrm>
+            <a:off x="1654800" y="6250000"/>
+            <a:ext cx="228600" cy="228600"/>
+          </a:xfrm>
+          <a:prstGeom prst="rect">
+            <a:avLst/>
+          </a:prstGeom>
+          <a:solidFill>
+            <a:srgbClr val="00B050"/>
+          </a:solidFill>
+          <a:ln w="6350">
+            <a:solidFill>
+              <a:srgbClr val="7F7F7F"/>
+            </a:solidFill>
+          </a:ln>
+        </p:spPr>
+        <p:txBody>
+          <a:bodyPr wrap="none" lIns="0" tIns="0" rIns="0" bIns="0" anchor="ctr"/>
+          <a:lstStyle/>
+          <a:p>
+            <a:r>
+              <a:rPr lang="en-US" sz="1100">
+                <a:solidFill>
+                  <a:srgbClr val="404040"/>
+                </a:solidFill>
+              </a:rPr>
+              <a:t/>
+            </a:r>
+          </a:p>
+        </p:txBody>
+      </p:sp>
+      <p:sp>
+        <p:nvSpPr>
+          <p:cNvPr id="11" name="Legend 11"/>
+          <p:cNvSpPr txBox="1"/>
+          <p:nvPr/>
+        </p:nvSpPr>
+        <p:spPr>
+          <a:xfrm>
+            <a:off x="1954800" y="6250000"/>
+            <a:ext cx="650000" cy="228600"/>
+          </a:xfrm>
+          <a:prstGeom prst="rect">
+            <a:avLst/>
+          </a:prstGeom>
+          <a:noFill/>
+          <a:ln>
+            <a:noFill/>
+          </a:ln>
+        </p:spPr>
+        <p:txBody>
+          <a:bodyPr wrap="none" lIns="0" tIns="0" rIns="0" bIns="0" anchor="ctr"/>
+          <a:lstStyle/>
+          <a:p>
+            <a:r>
+              <a:rPr lang="en-US" sz="1100">
+                <a:solidFill>
+                  <a:srgbClr val="404040"/>
+                </a:solidFill>
+              </a:rPr>
+              <a:t>Strong</a:t>
+            </a:r>
+          </a:p>
+        </p:txBody>
+      </p:sp>
+      <p:sp>
+        <p:nvSpPr>
+          <p:cNvPr id="12" name="Legend 12"/>
+          <p:cNvSpPr txBox="0"/>
+          <p:nvPr/>
+        </p:nvSpPr>
+        <p:spPr>
+          <a:xfrm>
+            <a:off x="2654800" y="6250000"/>
+            <a:ext cx="228600" cy="228600"/>
+          </a:xfrm>
+          <a:prstGeom prst="rect">
+            <a:avLst/>
+          </a:prstGeom>
+          <a:solidFill>
+            <a:srgbClr val="FFFF00"/>
+          </a:solidFill>
+          <a:ln w="6350">
+            <a:solidFill>
+              <a:srgbClr val="7F7F7F"/>
+            </a:solidFill>
+          </a:ln>
+        </p:spPr>
+        <p:txBody>
+          <a:bodyPr wrap="none" lIns="0" tIns="0" rIns="0" bIns="0" anchor="ctr"/>
+          <a:lstStyle/>
+          <a:p>
+            <a:r>
+              <a:rPr lang="en-US" sz="1100">
+                <a:solidFill>
+                  <a:srgbClr val="404040"/>
+                </a:solidFill>
+              </a:rPr>
+              <a:t/>
+            </a:r>
+          </a:p>
+        </p:txBody>
+      </p:sp>
+      <p:sp>
+        <p:nvSpPr>
+          <p:cNvPr id="13" name="Legend 13"/>
+          <p:cNvSpPr txBox="1"/>
+          <p:nvPr/>
+        </p:nvSpPr>
+        <p:spPr>
+          <a:xfrm>
+            <a:off x="2954800" y="6250000"/>
+            <a:ext cx="650000" cy="228600"/>
+          </a:xfrm>
+          <a:prstGeom prst="rect">
+            <a:avLst/>
+          </a:prstGeom>
+          <a:noFill/>
+          <a:ln>
+            <a:noFill/>
+          </a:ln>
+        </p:spPr>
+        <p:txBody>
+          <a:bodyPr wrap="none" lIns="0" tIns="0" rIns="0" bIns="0" anchor="ctr"/>
+          <a:lstStyle/>
+          <a:p>
+            <a:r>
+              <a:rPr lang="en-US" sz="1100">
+                <a:solidFill>
+                  <a:srgbClr val="404040"/>
+                </a:solidFill>
+              </a:rPr>
+              <a:t>Fair</a:t>
+            </a:r>
+          </a:p>
+        </p:txBody>
+      </p:sp>
+      <p:sp>
+        <p:nvSpPr>
+          <p:cNvPr id="14" name="Legend 14"/>
+          <p:cNvSpPr txBox="0"/>
+          <p:nvPr/>
+        </p:nvSpPr>
+        <p:spPr>
+          <a:xfrm>
+            <a:off x="3654800" y="6250000"/>
+            <a:ext cx="228600" cy="228600"/>
+          </a:xfrm>
+          <a:prstGeom prst="rect">
+            <a:avLst/>
+          </a:prstGeom>
+          <a:solidFill>
+            <a:srgbClr val="FFC000"/>
+          </a:solidFill>
+          <a:ln w="6350">
+            <a:solidFill>
+              <a:srgbClr val="7F7F7F"/>
+            </a:solidFill>
+          </a:ln>
+        </p:spPr>
+        <p:txBody>
+          <a:bodyPr wrap="none" lIns="0" tIns="0" rIns="0" bIns="0" anchor="ctr"/>
+          <a:lstStyle/>
+          <a:p>
+            <a:r>
+              <a:rPr lang="en-US" sz="1100">
+                <a:solidFill>
+                  <a:srgbClr val="404040"/>
+                </a:solidFill>
+              </a:rPr>
+              <a:t/>
+            </a:r>
+          </a:p>
+        </p:txBody>
+      </p:sp>
+      <p:sp>
+        <p:nvSpPr>
+          <p:cNvPr id="15" name="Legend 15"/>
+          <p:cNvSpPr txBox="1"/>
+          <p:nvPr/>
+        </p:nvSpPr>
+        <p:spPr>
+          <a:xfrm>
+            <a:off x="3954800" y="6250000"/>
+            <a:ext cx="650000" cy="228600"/>
+          </a:xfrm>
+          <a:prstGeom prst="rect">
+            <a:avLst/>
+          </a:prstGeom>
+          <a:noFill/>
+          <a:ln>
+            <a:noFill/>
+          </a:ln>
+        </p:spPr>
+        <p:txBody>
+          <a:bodyPr wrap="none" lIns="0" tIns="0" rIns="0" bIns="0" anchor="ctr"/>
+          <a:lstStyle/>
+          <a:p>
+            <a:r>
+              <a:rPr lang="en-US" sz="1100">
+                <a:solidFill>
+                  <a:srgbClr val="404040"/>
+                </a:solidFill>
+              </a:rPr>
+              <a:t>Weak</a:t>
+            </a:r>
+          </a:p>
+        </p:txBody>
+      </p:sp>
+      <p:sp>
+        <p:nvSpPr>
+          <p:cNvPr id="16" name="Legend 16"/>
+          <p:cNvSpPr txBox="0"/>
+          <p:nvPr/>
+        </p:nvSpPr>
+        <p:spPr>
+          <a:xfrm>
+            <a:off x="4654800" y="6250000"/>
+            <a:ext cx="228600" cy="228600"/>
+          </a:xfrm>
+          <a:prstGeom prst="rect">
+            <a:avLst/>
+          </a:prstGeom>
+          <a:solidFill>
+            <a:srgbClr val="FF9999"/>
+          </a:solidFill>
+          <a:ln w="6350">
+            <a:solidFill>
+              <a:srgbClr val="7F7F7F"/>
+            </a:solidFill>
+          </a:ln>
+        </p:spPr>
+        <p:txBody>
+          <a:bodyPr wrap="none" lIns="0" tIns="0" rIns="0" bIns="0" anchor="ctr"/>
+          <a:lstStyle/>
+          <a:p>
+            <a:r>
+              <a:rPr lang="en-US" sz="1100">
+                <a:solidFill>
+                  <a:srgbClr val="404040"/>
+                </a:solidFill>
+              </a:rPr>
+              <a:t/>
+            </a:r>
+          </a:p>
+        </p:txBody>
+      </p:sp>
+      <p:sp>
+        <p:nvSpPr>
+          <p:cNvPr id="17" name="Legend 17"/>
+          <p:cNvSpPr txBox="1"/>
+          <p:nvPr/>
+        </p:nvSpPr>
+        <p:spPr>
+          <a:xfrm>
+            <a:off x="4954800" y="6250000"/>
+            <a:ext cx="650000" cy="228600"/>
+          </a:xfrm>
+          <a:prstGeom prst="rect">
+            <a:avLst/>
+          </a:prstGeom>
+          <a:noFill/>
+          <a:ln>
+            <a:noFill/>
+          </a:ln>
+        </p:spPr>
+        <p:txBody>
+          <a:bodyPr wrap="none" lIns="0" tIns="0" rIns="0" bIns="0" anchor="ctr"/>
+          <a:lstStyle/>
+          <a:p>
+            <a:r>
+              <a:rPr lang="en-US" sz="1100">
+                <a:solidFill>
+                  <a:srgbClr val="404040"/>
+                </a:solidFill>
+              </a:rPr>
+              <a:t>Poor</a:t>
+            </a:r>
+          </a:p>
+        </p:txBody>
+      </p:sp>
     </p:spTree>
     <p:extLst>
       <p:ext uri="{BB962C8B-B14F-4D97-AF65-F5344CB8AC3E}">
@@ -17095,7 +17417,7 @@
         </p:nvSpPr>
         <p:spPr>
           <a:xfrm>
-            <a:off x="838199" y="87766"/>
+            <a:off x="304800" y="87766"/>
             <a:ext cx="10515600" cy="602348"/>
           </a:xfrm>
         </p:spPr>
@@ -17107,7 +17429,7 @@
           <a:p>
             <a:r>
               <a:rPr lang="en-US" dirty="0"/>
-              <a:t>Detractors – “Leaky Bucket”</a:t>
+              <a:t>Leaky Bucket: Service and Logistics</a:t>
             </a:r>
           </a:p>
         </p:txBody>
@@ -17159,8 +17481,8 @@
           </p:nvPr>
         </p:nvGraphicFramePr>
         <p:xfrm>
-          <a:off x="-1" y="815004"/>
-          <a:ext cx="12192000" cy="5100768"/>
+          <a:off x="304800" y="815004"/>
+          <a:ext cx="11582400" cy="5100768"/>
         </p:xfrm>
         <a:graphic>
           <a:graphicData uri="http://schemas.openxmlformats.org/drawingml/2006/table">
@@ -17169,28 +17491,28 @@
                 <a:tableStyleId>{5C22544A-7EE6-4342-B048-85BDC9FD1C3A}</a:tableStyleId>
               </a:tblPr>
               <a:tblGrid>
-                <a:gridCol w="2156604">
+                <a:gridCol w="2300000">
                   <a:extLst>
                     <a:ext uri="{9D8B030D-6E8A-4147-A177-3AD203B41FA5}">
                       <a16:colId xmlns:a16="http://schemas.microsoft.com/office/drawing/2014/main" val="3044332699"/>
                     </a:ext>
                   </a:extLst>
                 </a:gridCol>
-                <a:gridCol w="1319841">
+                <a:gridCol w="900000">
                   <a:extLst>
                     <a:ext uri="{9D8B030D-6E8A-4147-A177-3AD203B41FA5}">
                       <a16:colId xmlns:a16="http://schemas.microsoft.com/office/drawing/2014/main" val="3713660959"/>
                     </a:ext>
                   </a:extLst>
                 </a:gridCol>
-                <a:gridCol w="3519578">
+                <a:gridCol w="3900000">
                   <a:extLst>
                     <a:ext uri="{9D8B030D-6E8A-4147-A177-3AD203B41FA5}">
                       <a16:colId xmlns:a16="http://schemas.microsoft.com/office/drawing/2014/main" val="388891247"/>
                     </a:ext>
                   </a:extLst>
                 </a:gridCol>
-                <a:gridCol w="5195977">
+                <a:gridCol w="4482400">
                   <a:extLst>
                     <a:ext uri="{9D8B030D-6E8A-4147-A177-3AD203B41FA5}">
                       <a16:colId xmlns:a16="http://schemas.microsoft.com/office/drawing/2014/main" val="3762181464"/>
@@ -17205,7 +17527,7 @@
                     <a:lstStyle/>
                     <a:p>
                       <a:r>
-                        <a:rPr lang="en-US" sz="1000" dirty="0"/>
+                        <a:rPr lang="en-US" sz="1100" dirty="0"/>
                         <a:t>Possible Detractor</a:t>
                       </a:r>
                     </a:p>
@@ -17255,7 +17577,7 @@
                     <a:lstStyle/>
                     <a:p>
                       <a:r>
-                        <a:rPr lang="en-US" sz="1000" dirty="0"/>
+                        <a:rPr lang="en-US" sz="1100" dirty="0"/>
                         <a:t>Henry’s Position</a:t>
                       </a:r>
                     </a:p>
@@ -17305,8 +17627,8 @@
                     <a:lstStyle/>
                     <a:p>
                       <a:r>
-                        <a:rPr lang="en-US" sz="1000" dirty="0"/>
-                        <a:t>NOTES</a:t>
+                        <a:rPr lang="en-US" sz="1100" dirty="0"/>
+                        <a:t>Notes</a:t>
                       </a:r>
                     </a:p>
                   </a:txBody>
@@ -17355,8 +17677,8 @@
                     <a:lstStyle/>
                     <a:p>
                       <a:r>
-                        <a:rPr lang="en-US" sz="1000" dirty="0"/>
-                        <a:t>FIX</a:t>
+                        <a:rPr lang="en-US" sz="1100" dirty="0"/>
+                        <a:t>Fix</a:t>
                       </a:r>
                     </a:p>
                   </a:txBody>
@@ -17412,7 +17734,7 @@
                     <a:lstStyle/>
                     <a:p>
                       <a:r>
-                        <a:rPr lang="en-US" sz="1000" b="1" dirty="0"/>
+                        <a:rPr lang="en-US" sz="1100" b="1" dirty="0"/>
                         <a:t>Service</a:t>
                       </a:r>
                     </a:p>
@@ -17464,7 +17786,7 @@
                     <a:bodyPr/>
                     <a:lstStyle/>
                     <a:p>
-                      <a:endParaRPr lang="en-US" sz="1000" dirty="0"/>
+                      <a:endParaRPr lang="en-US" sz="1100" dirty="0"/>
                     </a:p>
                   </a:txBody>
                   <a:tcPr>
@@ -17515,7 +17837,7 @@
                     <a:lstStyle/>
                     <a:p>
                       <a:r>
-                        <a:rPr lang="en-US" sz="1000" dirty="0"/>
+                        <a:rPr lang="en-US" sz="1100" dirty="0"/>
                         <a:t>Consistent feedback: we’re difficult to deal with</a:t>
                       </a:r>
                     </a:p>
@@ -17568,7 +17890,7 @@
                     <a:lstStyle/>
                     <a:p>
                       <a:r>
-                        <a:rPr lang="en-US" sz="1000" dirty="0"/>
+                        <a:rPr lang="en-US" sz="1100" dirty="0"/>
                         <a:t>Hold people accountable</a:t>
                       </a:r>
                     </a:p>
@@ -17627,12 +17949,12 @@
                     <a:bodyPr/>
                     <a:lstStyle/>
                     <a:p>
-                      <a:pPr marL="285750" indent="-285750">
+                      <a:pPr marL="171450" indent="-171450">
                         <a:buFont typeface="Arial" panose="020B0604020202020204" pitchFamily="34" charset="0"/>
                         <a:buChar char="•"/>
                       </a:pPr>
                       <a:r>
-                        <a:rPr lang="en-US" sz="1000" dirty="0"/>
+                        <a:rPr lang="en-US" sz="1100" dirty="0"/>
                         <a:t>Cumbersome order taking</a:t>
                       </a:r>
                     </a:p>
@@ -17681,7 +18003,7 @@
                     <a:bodyPr/>
                     <a:lstStyle/>
                     <a:p>
-                      <a:endParaRPr lang="en-US" sz="1000" dirty="0"/>
+                      <a:endParaRPr lang="en-US" sz="1100" dirty="0"/>
                     </a:p>
                   </a:txBody>
                   <a:tcPr>
@@ -17732,7 +18054,7 @@
                     <a:lstStyle/>
                     <a:p>
                       <a:r>
-                        <a:rPr lang="en-US" sz="1000" dirty="0"/>
+                        <a:rPr lang="en-US" sz="1100" dirty="0"/>
                         <a:t>Customer asks for “24 drums of white silicone”; CS replies with a 200-SKU Excel file asking for the SAP #</a:t>
                       </a:r>
                     </a:p>
@@ -17783,7 +18105,7 @@
                     <a:lstStyle/>
                     <a:p>
                       <a:r>
-                        <a:rPr lang="en-US" sz="1000" dirty="0"/>
+                        <a:rPr lang="en-US" sz="1100" dirty="0"/>
                         <a:t>Take orders as written; call the customer if unclear. Hold customers to the Order Acknowledgement. Rely less on sales.</a:t>
                       </a:r>
                     </a:p>
@@ -17840,12 +18162,12 @@
                     <a:bodyPr/>
                     <a:lstStyle/>
                     <a:p>
-                      <a:pPr marL="285750" indent="-285750">
+                      <a:pPr marL="171450" indent="-171450">
                         <a:buFont typeface="Arial" panose="020B0604020202020204" pitchFamily="34" charset="0"/>
                         <a:buChar char="•"/>
                       </a:pPr>
                       <a:r>
-                        <a:rPr lang="en-US" sz="1000" dirty="0"/>
+                        <a:rPr lang="en-US" sz="1100" dirty="0"/>
                         <a:t>Slow responses</a:t>
                       </a:r>
                     </a:p>
@@ -17894,7 +18216,7 @@
                     <a:bodyPr/>
                     <a:lstStyle/>
                     <a:p>
-                      <a:endParaRPr lang="en-US" sz="1000" dirty="0"/>
+                      <a:endParaRPr lang="en-US" sz="1100" dirty="0"/>
                     </a:p>
                   </a:txBody>
                   <a:tcPr>
@@ -17945,7 +18267,7 @@
                     <a:lstStyle/>
                     <a:p>
                       <a:r>
-                        <a:rPr lang="en-US" sz="1000" dirty="0"/>
+                        <a:rPr lang="en-US" sz="1100" dirty="0"/>
                         <a:t>Inquiries (not orders) can take 24+ hours</a:t>
                       </a:r>
                     </a:p>
@@ -17996,7 +18318,7 @@
                     <a:lstStyle/>
                     <a:p>
                       <a:r>
-                        <a:rPr lang="en-US" sz="1000" dirty="0"/>
+                        <a:rPr lang="en-US" sz="1100" dirty="0"/>
                         <a:t>4-hour response on all emails</a:t>
                       </a:r>
                     </a:p>
@@ -18053,12 +18375,12 @@
                     <a:bodyPr/>
                     <a:lstStyle/>
                     <a:p>
-                      <a:pPr marL="285750" indent="-285750">
+                      <a:pPr marL="171450" indent="-171450">
                         <a:buFont typeface="Arial" panose="020B0604020202020204" pitchFamily="34" charset="0"/>
                         <a:buChar char="•"/>
                       </a:pPr>
                       <a:r>
-                        <a:rPr lang="en-US" sz="1000" dirty="0"/>
+                        <a:rPr lang="en-US" sz="1100" dirty="0"/>
                         <a:t>Inflexible on requests (substitutions, alternate plants, expediting)</a:t>
                       </a:r>
                     </a:p>
@@ -18107,7 +18429,7 @@
                     <a:bodyPr/>
                     <a:lstStyle/>
                     <a:p>
-                      <a:endParaRPr lang="en-US" sz="1000" dirty="0"/>
+                      <a:endParaRPr lang="en-US" sz="1100" dirty="0"/>
                     </a:p>
                   </a:txBody>
                   <a:tcPr>
@@ -18158,7 +18480,7 @@
                     <a:lstStyle/>
                     <a:p>
                       <a:r>
-                        <a:rPr lang="en-US" sz="1000" dirty="0"/>
+                        <a:rPr lang="en-US" sz="1100" dirty="0"/>
                         <a:t>If Kingman is out of PG988 but Carson has it, CS should get it to the customer fast, especially when a date is requested</a:t>
                       </a:r>
                     </a:p>
@@ -18209,7 +18531,7 @@
                     <a:lstStyle/>
                     <a:p>
                       <a:r>
-                        <a:rPr lang="en-US" sz="1000" dirty="0"/>
+                        <a:rPr lang="en-US" sz="1100" dirty="0"/>
                         <a:t>Give CS inventory visibility across all plants. Train staff on approved substitutions.</a:t>
                       </a:r>
                     </a:p>
@@ -18271,7 +18593,7 @@
                         <a:buChar char="•"/>
                       </a:pPr>
                       <a:r>
-                        <a:rPr lang="en-US" sz="1000" b="0" dirty="0"/>
+                        <a:rPr lang="en-US" sz="1100" b="0" dirty="0"/>
                         <a:t>Slow Warranty Sign-Offs</a:t>
                       </a:r>
                     </a:p>
@@ -18324,7 +18646,7 @@
                         <a:buFont typeface="Arial" panose="020B0604020202020204" pitchFamily="34" charset="0"/>
                         <a:buChar char="•"/>
                       </a:pPr>
-                      <a:endParaRPr lang="en-US" sz="1000" b="0" dirty="0"/>
+                      <a:endParaRPr lang="en-US" sz="1100" b="0" dirty="0"/>
                     </a:p>
                   </a:txBody>
                   <a:tcPr>
@@ -18379,7 +18701,7 @@
                         <a:buNone/>
                       </a:pPr>
                       <a:r>
-                        <a:rPr lang="en-US" sz="1000" b="0" dirty="0"/>
+                        <a:rPr lang="en-US" sz="1100" b="0" dirty="0"/>
                         <a:t>Some manufacturers sign off without walking the site</a:t>
                       </a:r>
                     </a:p>
@@ -18434,7 +18756,7 @@
                         <a:buNone/>
                       </a:pPr>
                       <a:r>
-                        <a:rPr lang="en-US" sz="1000" b="0" dirty="0"/>
+                        <a:rPr lang="en-US" sz="1100" b="0" dirty="0"/>
                         <a:t>Sign off ASAP; walk the roof within the roofer’s 2-year leak window. Batch sign-offs 3+ hours from base to cut travel.</a:t>
                       </a:r>
                     </a:p>
@@ -18496,7 +18818,7 @@
                         <a:buChar char="•"/>
                       </a:pPr>
                       <a:r>
-                        <a:rPr lang="en-US" sz="1000" b="0" dirty="0"/>
+                        <a:rPr lang="en-US" sz="1100" b="0" dirty="0"/>
                         <a:t>Slow Warranty Claim Responses</a:t>
                       </a:r>
                     </a:p>
@@ -18549,7 +18871,7 @@
                         <a:buFont typeface="Arial" panose="020B0604020202020204" pitchFamily="34" charset="0"/>
                         <a:buChar char="•"/>
                       </a:pPr>
-                      <a:endParaRPr lang="en-US" sz="1000" b="0" dirty="0"/>
+                      <a:endParaRPr lang="en-US" sz="1100" b="0" dirty="0"/>
                     </a:p>
                   </a:txBody>
                   <a:tcPr>
@@ -18604,7 +18926,7 @@
                         <a:buNone/>
                       </a:pPr>
                       <a:r>
-                        <a:rPr lang="en-US" sz="1000" b="0" dirty="0"/>
+                        <a:rPr lang="en-US" sz="1100" b="0" dirty="0"/>
                         <a:t>Building owners expect action within 24 hours</a:t>
                       </a:r>
                     </a:p>
@@ -18659,7 +18981,7 @@
                         <a:buNone/>
                       </a:pPr>
                       <a:r>
-                        <a:rPr lang="en-US" sz="1000" b="0" dirty="0"/>
+                        <a:rPr lang="en-US" sz="1100" b="0" dirty="0"/>
                         <a:t>Email acknowledgement in 4 hours; site visit in 4 days</a:t>
                       </a:r>
                     </a:p>
@@ -18717,7 +19039,7 @@
                     <a:lstStyle/>
                     <a:p>
                       <a:r>
-                        <a:rPr lang="en-US" sz="1000" b="1" dirty="0"/>
+                        <a:rPr lang="en-US" sz="1100" b="1" dirty="0"/>
                         <a:t>Logistics</a:t>
                       </a:r>
                     </a:p>
@@ -18769,7 +19091,7 @@
                     <a:bodyPr/>
                     <a:lstStyle/>
                     <a:p>
-                      <a:endParaRPr lang="en-US" sz="1000" dirty="0"/>
+                      <a:endParaRPr lang="en-US" sz="1100" dirty="0"/>
                     </a:p>
                   </a:txBody>
                   <a:tcPr>
@@ -18820,7 +19142,7 @@
                     <a:lstStyle/>
                     <a:p>
                       <a:r>
-                        <a:rPr lang="en-US" sz="1000" dirty="0"/>
+                        <a:rPr lang="en-US" sz="1100" dirty="0"/>
                         <a:t>Feedback: we’re unreliable</a:t>
                       </a:r>
                     </a:p>
@@ -18873,10 +19195,10 @@
                     <a:lstStyle/>
                     <a:p>
                       <a:r>
-                        <a:rPr lang="en-US" sz="1000" dirty="0"/>
+                        <a:rPr lang="en-US" sz="1100" dirty="0"/>
                         <a:t>Push roofers to distribution (solve pricing). Trackers on pallets. CS updates customers daily, unprompted.</a:t>
                       </a:r>
-                      <a:endParaRPr lang="en-US" sz="1000" u="sng" dirty="0"/>
+                      <a:endParaRPr lang="en-US" sz="1100" u="sng" dirty="0"/>
                     </a:p>
                   </a:txBody>
                   <a:tcPr>
@@ -18933,12 +19255,12 @@
                     <a:bodyPr/>
                     <a:lstStyle/>
                     <a:p>
-                      <a:pPr marL="285750" indent="-285750">
+                      <a:pPr marL="171450" indent="-171450">
                         <a:buFont typeface="Arial" panose="020B0604020202020204" pitchFamily="34" charset="0"/>
                         <a:buChar char="•"/>
                       </a:pPr>
                       <a:r>
-                        <a:rPr lang="en-US" sz="1000" dirty="0"/>
+                        <a:rPr lang="en-US" sz="1100" dirty="0"/>
                         <a:t>No notifications/tracking</a:t>
                       </a:r>
                     </a:p>
@@ -18987,7 +19309,7 @@
                     <a:bodyPr/>
                     <a:lstStyle/>
                     <a:p>
-                      <a:endParaRPr lang="en-US" sz="1000" dirty="0"/>
+                      <a:endParaRPr lang="en-US" sz="1100" dirty="0"/>
                     </a:p>
                   </a:txBody>
                   <a:tcPr>
@@ -19038,7 +19360,7 @@
                     <a:lstStyle/>
                     <a:p>
                       <a:r>
-                        <a:rPr lang="en-US" sz="1000" dirty="0"/>
+                        <a:rPr lang="en-US" sz="1100" dirty="0"/>
                         <a:t>Material arrives days or weeks early with no one to accept it. Mainly hurts the roofer, but makes Henry/Carlisle look unprofessional too.</a:t>
                       </a:r>
                     </a:p>
@@ -19088,7 +19410,11 @@
                     <a:bodyPr/>
                     <a:lstStyle/>
                     <a:p>
-                      <a:endParaRPr lang="en-US" sz="1000" dirty="0"/>
+                      <a:r>
+                        <a:rPr lang="en-US" sz="1100"/>
+                        <a:t>Covered by the Logistics fixes above</a:t>
+                      </a:r>
+                      <a:endParaRPr lang="en-US" sz="1100" dirty="0"/>
                     </a:p>
                   </a:txBody>
                   <a:tcPr>
@@ -19143,12 +19469,12 @@
                     <a:bodyPr/>
                     <a:lstStyle/>
                     <a:p>
-                      <a:pPr marL="285750" indent="-285750">
+                      <a:pPr marL="171450" indent="-171450">
                         <a:buFont typeface="Arial" panose="020B0604020202020204" pitchFamily="34" charset="0"/>
                         <a:buChar char="•"/>
                       </a:pPr>
                       <a:r>
-                        <a:rPr lang="en-US" sz="1000" dirty="0"/>
+                        <a:rPr lang="en-US" sz="1100" dirty="0"/>
                         <a:t>Shipping at Henry’s convenience, not the customer’s</a:t>
                       </a:r>
                     </a:p>
@@ -19197,7 +19523,7 @@
                     <a:bodyPr/>
                     <a:lstStyle/>
                     <a:p>
-                      <a:endParaRPr lang="en-US" sz="1000" dirty="0"/>
+                      <a:endParaRPr lang="en-US" sz="1100" dirty="0"/>
                     </a:p>
                   </a:txBody>
                   <a:tcPr>
@@ -19248,7 +19574,7 @@
                     <a:lstStyle/>
                     <a:p>
                       <a:r>
-                        <a:rPr lang="en-US" sz="1000" dirty="0"/>
+                        <a:rPr lang="en-US" sz="1100" dirty="0"/>
                         <a:t>With no requested date, we set one on the OA, then ship early without notice. Sometimes no one is there to receive it.</a:t>
                       </a:r>
                     </a:p>
@@ -19299,7 +19625,7 @@
                     <a:lstStyle/>
                     <a:p>
                       <a:r>
-                        <a:rPr lang="en-US" sz="1000" dirty="0"/>
+                        <a:rPr lang="en-US" sz="1100" dirty="0"/>
                         <a:t>Keep the customer informed. Ask before shipping early. Provide tracking and daily updates.</a:t>
                       </a:r>
                     </a:p>
@@ -19354,6 +19680,328 @@
           </a:graphicData>
         </a:graphic>
       </p:graphicFrame>
+      <p:sp>
+        <p:nvSpPr>
+          <p:cNvPr id="11" name="Legend 11"/>
+          <p:cNvSpPr txBox="1"/>
+          <p:nvPr/>
+        </p:nvSpPr>
+        <p:spPr>
+          <a:xfrm>
+            <a:off x="304800" y="6250000"/>
+            <a:ext cx="1300000" cy="228600"/>
+          </a:xfrm>
+          <a:prstGeom prst="rect">
+            <a:avLst/>
+          </a:prstGeom>
+          <a:noFill/>
+          <a:ln>
+            <a:noFill/>
+          </a:ln>
+        </p:spPr>
+        <p:txBody>
+          <a:bodyPr wrap="none" lIns="0" tIns="0" rIns="0" bIns="0" anchor="ctr"/>
+          <a:lstStyle/>
+          <a:p>
+            <a:r>
+              <a:rPr lang="en-US" sz="1100" b="1">
+                <a:solidFill>
+                  <a:srgbClr val="404040"/>
+                </a:solidFill>
+              </a:rPr>
+              <a:t>Henry's position:</a:t>
+            </a:r>
+          </a:p>
+        </p:txBody>
+      </p:sp>
+      <p:sp>
+        <p:nvSpPr>
+          <p:cNvPr id="12" name="Legend 12"/>
+          <p:cNvSpPr txBox="0"/>
+          <p:nvPr/>
+        </p:nvSpPr>
+        <p:spPr>
+          <a:xfrm>
+            <a:off x="1654800" y="6250000"/>
+            <a:ext cx="228600" cy="228600"/>
+          </a:xfrm>
+          <a:prstGeom prst="rect">
+            <a:avLst/>
+          </a:prstGeom>
+          <a:solidFill>
+            <a:srgbClr val="00B050"/>
+          </a:solidFill>
+          <a:ln w="6350">
+            <a:solidFill>
+              <a:srgbClr val="7F7F7F"/>
+            </a:solidFill>
+          </a:ln>
+        </p:spPr>
+        <p:txBody>
+          <a:bodyPr wrap="none" lIns="0" tIns="0" rIns="0" bIns="0" anchor="ctr"/>
+          <a:lstStyle/>
+          <a:p>
+            <a:r>
+              <a:rPr lang="en-US" sz="1100">
+                <a:solidFill>
+                  <a:srgbClr val="404040"/>
+                </a:solidFill>
+              </a:rPr>
+              <a:t/>
+            </a:r>
+          </a:p>
+        </p:txBody>
+      </p:sp>
+      <p:sp>
+        <p:nvSpPr>
+          <p:cNvPr id="13" name="Legend 13"/>
+          <p:cNvSpPr txBox="1"/>
+          <p:nvPr/>
+        </p:nvSpPr>
+        <p:spPr>
+          <a:xfrm>
+            <a:off x="1954800" y="6250000"/>
+            <a:ext cx="650000" cy="228600"/>
+          </a:xfrm>
+          <a:prstGeom prst="rect">
+            <a:avLst/>
+          </a:prstGeom>
+          <a:noFill/>
+          <a:ln>
+            <a:noFill/>
+          </a:ln>
+        </p:spPr>
+        <p:txBody>
+          <a:bodyPr wrap="none" lIns="0" tIns="0" rIns="0" bIns="0" anchor="ctr"/>
+          <a:lstStyle/>
+          <a:p>
+            <a:r>
+              <a:rPr lang="en-US" sz="1100">
+                <a:solidFill>
+                  <a:srgbClr val="404040"/>
+                </a:solidFill>
+              </a:rPr>
+              <a:t>Strong</a:t>
+            </a:r>
+          </a:p>
+        </p:txBody>
+      </p:sp>
+      <p:sp>
+        <p:nvSpPr>
+          <p:cNvPr id="14" name="Legend 14"/>
+          <p:cNvSpPr txBox="0"/>
+          <p:nvPr/>
+        </p:nvSpPr>
+        <p:spPr>
+          <a:xfrm>
+            <a:off x="2654800" y="6250000"/>
+            <a:ext cx="228600" cy="228600"/>
+          </a:xfrm>
+          <a:prstGeom prst="rect">
+            <a:avLst/>
+          </a:prstGeom>
+          <a:solidFill>
+            <a:srgbClr val="FFFF00"/>
+          </a:solidFill>
+          <a:ln w="6350">
+            <a:solidFill>
+              <a:srgbClr val="7F7F7F"/>
+            </a:solidFill>
+          </a:ln>
+        </p:spPr>
+        <p:txBody>
+          <a:bodyPr wrap="none" lIns="0" tIns="0" rIns="0" bIns="0" anchor="ctr"/>
+          <a:lstStyle/>
+          <a:p>
+            <a:r>
+              <a:rPr lang="en-US" sz="1100">
+                <a:solidFill>
+                  <a:srgbClr val="404040"/>
+                </a:solidFill>
+              </a:rPr>
+              <a:t/>
+            </a:r>
+          </a:p>
+        </p:txBody>
+      </p:sp>
+      <p:sp>
+        <p:nvSpPr>
+          <p:cNvPr id="15" name="Legend 15"/>
+          <p:cNvSpPr txBox="1"/>
+          <p:nvPr/>
+        </p:nvSpPr>
+        <p:spPr>
+          <a:xfrm>
+            <a:off x="2954800" y="6250000"/>
+            <a:ext cx="650000" cy="228600"/>
+          </a:xfrm>
+          <a:prstGeom prst="rect">
+            <a:avLst/>
+          </a:prstGeom>
+          <a:noFill/>
+          <a:ln>
+            <a:noFill/>
+          </a:ln>
+        </p:spPr>
+        <p:txBody>
+          <a:bodyPr wrap="none" lIns="0" tIns="0" rIns="0" bIns="0" anchor="ctr"/>
+          <a:lstStyle/>
+          <a:p>
+            <a:r>
+              <a:rPr lang="en-US" sz="1100">
+                <a:solidFill>
+                  <a:srgbClr val="404040"/>
+                </a:solidFill>
+              </a:rPr>
+              <a:t>Fair</a:t>
+            </a:r>
+          </a:p>
+        </p:txBody>
+      </p:sp>
+      <p:sp>
+        <p:nvSpPr>
+          <p:cNvPr id="16" name="Legend 16"/>
+          <p:cNvSpPr txBox="0"/>
+          <p:nvPr/>
+        </p:nvSpPr>
+        <p:spPr>
+          <a:xfrm>
+            <a:off x="3654800" y="6250000"/>
+            <a:ext cx="228600" cy="228600"/>
+          </a:xfrm>
+          <a:prstGeom prst="rect">
+            <a:avLst/>
+          </a:prstGeom>
+          <a:solidFill>
+            <a:srgbClr val="FFC000"/>
+          </a:solidFill>
+          <a:ln w="6350">
+            <a:solidFill>
+              <a:srgbClr val="7F7F7F"/>
+            </a:solidFill>
+          </a:ln>
+        </p:spPr>
+        <p:txBody>
+          <a:bodyPr wrap="none" lIns="0" tIns="0" rIns="0" bIns="0" anchor="ctr"/>
+          <a:lstStyle/>
+          <a:p>
+            <a:r>
+              <a:rPr lang="en-US" sz="1100">
+                <a:solidFill>
+                  <a:srgbClr val="404040"/>
+                </a:solidFill>
+              </a:rPr>
+              <a:t/>
+            </a:r>
+          </a:p>
+        </p:txBody>
+      </p:sp>
+      <p:sp>
+        <p:nvSpPr>
+          <p:cNvPr id="17" name="Legend 17"/>
+          <p:cNvSpPr txBox="1"/>
+          <p:nvPr/>
+        </p:nvSpPr>
+        <p:spPr>
+          <a:xfrm>
+            <a:off x="3954800" y="6250000"/>
+            <a:ext cx="650000" cy="228600"/>
+          </a:xfrm>
+          <a:prstGeom prst="rect">
+            <a:avLst/>
+          </a:prstGeom>
+          <a:noFill/>
+          <a:ln>
+            <a:noFill/>
+          </a:ln>
+        </p:spPr>
+        <p:txBody>
+          <a:bodyPr wrap="none" lIns="0" tIns="0" rIns="0" bIns="0" anchor="ctr"/>
+          <a:lstStyle/>
+          <a:p>
+            <a:r>
+              <a:rPr lang="en-US" sz="1100">
+                <a:solidFill>
+                  <a:srgbClr val="404040"/>
+                </a:solidFill>
+              </a:rPr>
+              <a:t>Weak</a:t>
+            </a:r>
+          </a:p>
+        </p:txBody>
+      </p:sp>
+      <p:sp>
+        <p:nvSpPr>
+          <p:cNvPr id="18" name="Legend 18"/>
+          <p:cNvSpPr txBox="0"/>
+          <p:nvPr/>
+        </p:nvSpPr>
+        <p:spPr>
+          <a:xfrm>
+            <a:off x="4654800" y="6250000"/>
+            <a:ext cx="228600" cy="228600"/>
+          </a:xfrm>
+          <a:prstGeom prst="rect">
+            <a:avLst/>
+          </a:prstGeom>
+          <a:solidFill>
+            <a:srgbClr val="FF9999"/>
+          </a:solidFill>
+          <a:ln w="6350">
+            <a:solidFill>
+              <a:srgbClr val="7F7F7F"/>
+            </a:solidFill>
+          </a:ln>
+        </p:spPr>
+        <p:txBody>
+          <a:bodyPr wrap="none" lIns="0" tIns="0" rIns="0" bIns="0" anchor="ctr"/>
+          <a:lstStyle/>
+          <a:p>
+            <a:r>
+              <a:rPr lang="en-US" sz="1100">
+                <a:solidFill>
+                  <a:srgbClr val="404040"/>
+                </a:solidFill>
+              </a:rPr>
+              <a:t/>
+            </a:r>
+          </a:p>
+        </p:txBody>
+      </p:sp>
+      <p:sp>
+        <p:nvSpPr>
+          <p:cNvPr id="19" name="Legend 19"/>
+          <p:cNvSpPr txBox="1"/>
+          <p:nvPr/>
+        </p:nvSpPr>
+        <p:spPr>
+          <a:xfrm>
+            <a:off x="4954800" y="6250000"/>
+            <a:ext cx="650000" cy="228600"/>
+          </a:xfrm>
+          <a:prstGeom prst="rect">
+            <a:avLst/>
+          </a:prstGeom>
+          <a:noFill/>
+          <a:ln>
+            <a:noFill/>
+          </a:ln>
+        </p:spPr>
+        <p:txBody>
+          <a:bodyPr wrap="none" lIns="0" tIns="0" rIns="0" bIns="0" anchor="ctr"/>
+          <a:lstStyle/>
+          <a:p>
+            <a:r>
+              <a:rPr lang="en-US" sz="1100">
+                <a:solidFill>
+                  <a:srgbClr val="404040"/>
+                </a:solidFill>
+              </a:rPr>
+              <a:t>Poor</a:t>
+            </a:r>
+          </a:p>
+        </p:txBody>
+      </p:sp>
     </p:spTree>
     <p:extLst>
       <p:ext uri="{BB962C8B-B14F-4D97-AF65-F5344CB8AC3E}">
@@ -19408,7 +20056,7 @@
         </p:nvSpPr>
         <p:spPr>
           <a:xfrm>
-            <a:off x="838199" y="87766"/>
+            <a:off x="304800" y="87766"/>
             <a:ext cx="10515600" cy="602348"/>
           </a:xfrm>
         </p:spPr>
@@ -19420,7 +20068,7 @@
           <a:p>
             <a:r>
               <a:rPr lang="en-US" dirty="0"/>
-              <a:t>Detractors – “Leaky Bucket”</a:t>
+              <a:t>Leaky Bucket: Material, Systems and National Accounts</a:t>
             </a:r>
           </a:p>
         </p:txBody>
@@ -19472,8 +20120,8 @@
           </p:nvPr>
         </p:nvGraphicFramePr>
         <p:xfrm>
-          <a:off x="0" y="1199072"/>
-          <a:ext cx="12192000" cy="4105536"/>
+          <a:off x="304800" y="815004"/>
+          <a:ext cx="11582400" cy="4105536"/>
         </p:xfrm>
         <a:graphic>
           <a:graphicData uri="http://schemas.openxmlformats.org/drawingml/2006/table">
@@ -19482,28 +20130,28 @@
                 <a:tableStyleId>{5C22544A-7EE6-4342-B048-85BDC9FD1C3A}</a:tableStyleId>
               </a:tblPr>
               <a:tblGrid>
-                <a:gridCol w="2156604">
+                <a:gridCol w="2300000">
                   <a:extLst>
                     <a:ext uri="{9D8B030D-6E8A-4147-A177-3AD203B41FA5}">
                       <a16:colId xmlns:a16="http://schemas.microsoft.com/office/drawing/2014/main" val="3044332699"/>
                     </a:ext>
                   </a:extLst>
                 </a:gridCol>
-                <a:gridCol w="1319841">
+                <a:gridCol w="900000">
                   <a:extLst>
                     <a:ext uri="{9D8B030D-6E8A-4147-A177-3AD203B41FA5}">
                       <a16:colId xmlns:a16="http://schemas.microsoft.com/office/drawing/2014/main" val="3713660959"/>
                     </a:ext>
                   </a:extLst>
                 </a:gridCol>
-                <a:gridCol w="3519578">
+                <a:gridCol w="3900000">
                   <a:extLst>
                     <a:ext uri="{9D8B030D-6E8A-4147-A177-3AD203B41FA5}">
                       <a16:colId xmlns:a16="http://schemas.microsoft.com/office/drawing/2014/main" val="388891247"/>
                     </a:ext>
                   </a:extLst>
                 </a:gridCol>
-                <a:gridCol w="5195977">
+                <a:gridCol w="4482400">
                   <a:extLst>
                     <a:ext uri="{9D8B030D-6E8A-4147-A177-3AD203B41FA5}">
                       <a16:colId xmlns:a16="http://schemas.microsoft.com/office/drawing/2014/main" val="3762181464"/>
@@ -19518,7 +20166,7 @@
                     <a:lstStyle/>
                     <a:p>
                       <a:r>
-                        <a:rPr lang="en-US" sz="1000" dirty="0"/>
+                        <a:rPr lang="en-US" sz="1100" dirty="0"/>
                         <a:t>Possible Detractor</a:t>
                       </a:r>
                     </a:p>
@@ -19568,7 +20216,7 @@
                     <a:lstStyle/>
                     <a:p>
                       <a:r>
-                        <a:rPr lang="en-US" sz="1000" dirty="0"/>
+                        <a:rPr lang="en-US" sz="1100" dirty="0"/>
                         <a:t>Henry’s Position</a:t>
                       </a:r>
                     </a:p>
@@ -19618,8 +20266,8 @@
                     <a:lstStyle/>
                     <a:p>
                       <a:r>
-                        <a:rPr lang="en-US" sz="1000" dirty="0"/>
-                        <a:t>NOTES</a:t>
+                        <a:rPr lang="en-US" sz="1100" dirty="0"/>
+                        <a:t>Notes</a:t>
                       </a:r>
                     </a:p>
                   </a:txBody>
@@ -19668,8 +20316,8 @@
                     <a:lstStyle/>
                     <a:p>
                       <a:r>
-                        <a:rPr lang="en-US" sz="1000" dirty="0"/>
-                        <a:t>FIX</a:t>
+                        <a:rPr lang="en-US" sz="1100" dirty="0"/>
+                        <a:t>Fix</a:t>
                       </a:r>
                     </a:p>
                   </a:txBody>
@@ -19729,7 +20377,7 @@
                         <a:buNone/>
                       </a:pPr>
                       <a:r>
-                        <a:rPr lang="en-US" sz="1000" b="1" dirty="0"/>
+                        <a:rPr lang="en-US" sz="1100" b="1" dirty="0"/>
                         <a:t>Material and Systems</a:t>
                       </a:r>
                     </a:p>
@@ -19781,7 +20429,7 @@
                     <a:bodyPr/>
                     <a:lstStyle/>
                     <a:p>
-                      <a:endParaRPr lang="en-US" sz="1000" dirty="0"/>
+                      <a:endParaRPr lang="en-US" sz="1100" dirty="0"/>
                     </a:p>
                   </a:txBody>
                   <a:tcPr>
@@ -19831,7 +20479,7 @@
                     <a:bodyPr/>
                     <a:lstStyle/>
                     <a:p>
-                      <a:endParaRPr lang="en-US" sz="1000" dirty="0"/>
+                      <a:endParaRPr lang="en-US" sz="1100" dirty="0"/>
                     </a:p>
                   </a:txBody>
                   <a:tcPr>
@@ -19881,7 +20529,7 @@
                     <a:bodyPr/>
                     <a:lstStyle/>
                     <a:p>
-                      <a:endParaRPr lang="en-US" sz="1000" dirty="0"/>
+                      <a:endParaRPr lang="en-US" sz="1100" dirty="0"/>
                     </a:p>
                   </a:txBody>
                   <a:tcPr>
@@ -19943,7 +20591,7 @@
                         <a:buChar char="•"/>
                       </a:pPr>
                       <a:r>
-                        <a:rPr lang="en-US" sz="1000" b="0" dirty="0"/>
+                        <a:rPr lang="en-US" sz="1100" b="0" dirty="0"/>
                         <a:t>Material not ready to ship within 48 hours</a:t>
                       </a:r>
                     </a:p>
@@ -19992,7 +20640,7 @@
                     <a:bodyPr/>
                     <a:lstStyle/>
                     <a:p>
-                      <a:endParaRPr lang="en-US" sz="1000" dirty="0"/>
+                      <a:endParaRPr lang="en-US" sz="1100" dirty="0"/>
                     </a:p>
                   </a:txBody>
                   <a:tcPr>
@@ -20043,7 +20691,7 @@
                     <a:lstStyle/>
                     <a:p>
                       <a:r>
-                        <a:rPr lang="en-US" sz="1000" dirty="0"/>
+                        <a:rPr lang="en-US" sz="1100" dirty="0"/>
                         <a:t>Long-standing. Job-start items (primer, bleed blockers, mastics) must be in stock; trucks of 988 don’t help without primer.</a:t>
                       </a:r>
                     </a:p>
@@ -20094,7 +20742,7 @@
                     <a:lstStyle/>
                     <a:p>
                       <a:r>
-                        <a:rPr lang="en-US" sz="1000" dirty="0"/>
+                        <a:rPr lang="en-US" sz="1100" dirty="0"/>
                         <a:t>Raise accessory minimums. Ramp production ahead of known storms and weather.</a:t>
                       </a:r>
                     </a:p>
@@ -20156,7 +20804,7 @@
                         <a:buChar char="•"/>
                       </a:pPr>
                       <a:r>
-                        <a:rPr lang="en-US" sz="1000" b="0" dirty="0"/>
+                        <a:rPr lang="en-US" sz="1100" b="0" dirty="0"/>
                         <a:t>Inflexible on scope/specs</a:t>
                       </a:r>
                     </a:p>
@@ -20205,7 +20853,7 @@
                     <a:bodyPr/>
                     <a:lstStyle/>
                     <a:p>
-                      <a:endParaRPr lang="en-US" sz="1000" dirty="0"/>
+                      <a:endParaRPr lang="en-US" sz="1100" dirty="0"/>
                     </a:p>
                   </a:txBody>
                   <a:tcPr>
@@ -20256,7 +20904,7 @@
                     <a:lstStyle/>
                     <a:p>
                       <a:r>
-                        <a:rPr lang="en-US" sz="1000" dirty="0"/>
+                        <a:rPr lang="en-US" sz="1100" dirty="0"/>
                         <a:t>Many manufacturers require “less.” We will flex.</a:t>
                       </a:r>
                     </a:p>
@@ -20306,7 +20954,11 @@
                     <a:bodyPr/>
                     <a:lstStyle/>
                     <a:p>
-                      <a:endParaRPr lang="en-US" sz="1000" dirty="0"/>
+                      <a:r>
+                        <a:rPr lang="en-US" sz="1100"/>
+                        <a:t>None needed; protect this strength</a:t>
+                      </a:r>
+                      <a:endParaRPr lang="en-US" sz="1100" dirty="0"/>
                     </a:p>
                   </a:txBody>
                   <a:tcPr>
@@ -20366,7 +21018,7 @@
                         <a:buChar char="•"/>
                       </a:pPr>
                       <a:r>
-                        <a:rPr lang="en-US" sz="1000" b="0" dirty="0"/>
+                        <a:rPr lang="en-US" sz="1100" b="0" dirty="0"/>
                         <a:t>Failures</a:t>
                       </a:r>
                     </a:p>
@@ -20415,7 +21067,7 @@
                     <a:bodyPr/>
                     <a:lstStyle/>
                     <a:p>
-                      <a:endParaRPr lang="en-US" sz="1000" dirty="0"/>
+                      <a:endParaRPr lang="en-US" sz="1100" dirty="0"/>
                     </a:p>
                   </a:txBody>
                   <a:tcPr>
@@ -20466,7 +21118,7 @@
                     <a:lstStyle/>
                     <a:p>
                       <a:r>
-                        <a:rPr lang="en-US" sz="1000" dirty="0"/>
+                        <a:rPr lang="en-US" sz="1100" dirty="0"/>
                         <a:t>Failures kill future work with building owners</a:t>
                       </a:r>
                     </a:p>
@@ -20517,7 +21169,7 @@
                     <a:lstStyle/>
                     <a:p>
                       <a:r>
-                        <a:rPr lang="en-US" sz="1000" dirty="0"/>
+                        <a:rPr lang="en-US" sz="1100" dirty="0"/>
                         <a:t>Keep innovating</a:t>
                       </a:r>
                     </a:p>
@@ -20579,7 +21231,7 @@
                         <a:buChar char="•"/>
                       </a:pPr>
                       <a:r>
-                        <a:rPr lang="en-US" sz="1000" b="0" dirty="0"/>
+                        <a:rPr lang="en-US" sz="1100" b="0" dirty="0"/>
                         <a:t>Missing system components</a:t>
                       </a:r>
                     </a:p>
@@ -20628,7 +21280,7 @@
                     <a:bodyPr/>
                     <a:lstStyle/>
                     <a:p>
-                      <a:endParaRPr lang="en-US" sz="1000" dirty="0"/>
+                      <a:endParaRPr lang="en-US" sz="1100" dirty="0"/>
                     </a:p>
                   </a:txBody>
                   <a:tcPr>
@@ -20679,7 +21331,7 @@
                     <a:lstStyle/>
                     <a:p>
                       <a:r>
-                        <a:rPr lang="en-US" sz="1000" dirty="0"/>
+                        <a:rPr lang="en-US" sz="1100" dirty="0"/>
                         <a:t>No sprayable seam sealer for silicone systems; no cementitious coating for Arizona</a:t>
                       </a:r>
                     </a:p>
@@ -20729,7 +21381,11 @@
                     <a:bodyPr/>
                     <a:lstStyle/>
                     <a:p>
-                      <a:endParaRPr lang="en-US" sz="1000" dirty="0"/>
+                      <a:r>
+                        <a:rPr lang="en-US" sz="1100"/>
+                        <a:t>Assign an owner to close the gaps</a:t>
+                      </a:r>
+                      <a:endParaRPr lang="en-US" sz="1100" dirty="0"/>
                     </a:p>
                   </a:txBody>
                   <a:tcPr>
@@ -20789,7 +21445,7 @@
                         <a:buNone/>
                       </a:pPr>
                       <a:r>
-                        <a:rPr lang="en-US" sz="1000" b="1" dirty="0"/>
+                        <a:rPr lang="en-US" sz="1100" b="1" dirty="0"/>
                         <a:t>National Accounts</a:t>
                       </a:r>
                     </a:p>
@@ -20841,7 +21497,7 @@
                     <a:bodyPr/>
                     <a:lstStyle/>
                     <a:p>
-                      <a:endParaRPr lang="en-US" sz="1000" dirty="0"/>
+                      <a:endParaRPr lang="en-US" sz="1100" dirty="0"/>
                     </a:p>
                   </a:txBody>
                   <a:tcPr>
@@ -20891,7 +21547,7 @@
                     <a:bodyPr/>
                     <a:lstStyle/>
                     <a:p>
-                      <a:endParaRPr lang="en-US" sz="1000" dirty="0"/>
+                      <a:endParaRPr lang="en-US" sz="1100" dirty="0"/>
                     </a:p>
                   </a:txBody>
                   <a:tcPr>
@@ -20941,7 +21597,7 @@
                     <a:bodyPr/>
                     <a:lstStyle/>
                     <a:p>
-                      <a:endParaRPr lang="en-US" sz="1000" dirty="0"/>
+                      <a:endParaRPr lang="en-US" sz="1100" dirty="0"/>
                     </a:p>
                   </a:txBody>
                   <a:tcPr>
@@ -21003,7 +21659,7 @@
                         <a:buChar char="•"/>
                       </a:pPr>
                       <a:r>
-                        <a:rPr lang="en-US" sz="1000" b="0" dirty="0"/>
+                        <a:rPr lang="en-US" sz="1100" b="0" dirty="0"/>
                         <a:t>Leads that don’t close</a:t>
                       </a:r>
                     </a:p>
@@ -21052,7 +21708,7 @@
                     <a:bodyPr/>
                     <a:lstStyle/>
                     <a:p>
-                      <a:endParaRPr lang="en-US" sz="1000" dirty="0"/>
+                      <a:endParaRPr lang="en-US" sz="1100" dirty="0"/>
                     </a:p>
                   </a:txBody>
                   <a:tcPr>
@@ -21103,7 +21759,7 @@
                     <a:lstStyle/>
                     <a:p>
                       <a:r>
-                        <a:rPr lang="en-US" sz="1000" dirty="0"/>
+                        <a:rPr lang="en-US" sz="1100" dirty="0"/>
                         <a:t>National account leads close well; Facebook/website leads often don’t</a:t>
                       </a:r>
                     </a:p>
@@ -21154,7 +21810,7 @@
                     <a:lstStyle/>
                     <a:p>
                       <a:r>
-                        <a:rPr lang="en-US" sz="1000" dirty="0"/>
+                        <a:rPr lang="en-US" sz="1100" dirty="0"/>
                         <a:t>None needed</a:t>
                       </a:r>
                     </a:p>
@@ -21216,7 +21872,7 @@
                         <a:buChar char="•"/>
                       </a:pPr>
                       <a:r>
-                        <a:rPr lang="en-US" sz="1000" b="0" dirty="0"/>
+                        <a:rPr lang="en-US" sz="1100" b="0" dirty="0"/>
                         <a:t>Not enough leads</a:t>
                       </a:r>
                     </a:p>
@@ -21265,7 +21921,7 @@
                     <a:bodyPr/>
                     <a:lstStyle/>
                     <a:p>
-                      <a:endParaRPr lang="en-US" sz="1000" dirty="0"/>
+                      <a:endParaRPr lang="en-US" sz="1100" dirty="0"/>
                     </a:p>
                   </a:txBody>
                   <a:tcPr>
@@ -21316,7 +21972,7 @@
                     <a:lstStyle/>
                     <a:p>
                       <a:r>
-                        <a:rPr lang="en-US" sz="1000" dirty="0"/>
+                        <a:rPr lang="en-US" sz="1100" dirty="0"/>
                         <a:t>We’re a strong lead provider, but Sherwin-Williams supplies more through paint contracts</a:t>
                       </a:r>
                     </a:p>
@@ -21367,7 +22023,7 @@
                     <a:lstStyle/>
                     <a:p>
                       <a:r>
-                        <a:rPr lang="en-US" sz="1000" dirty="0"/>
+                        <a:rPr lang="en-US" sz="1100" dirty="0"/>
                         <a:t>Collaborate with other divisions. Free the national accounts team from firefighting and CS work to generate leads.</a:t>
                       </a:r>
                     </a:p>
@@ -21429,7 +22085,7 @@
                         <a:buChar char="•"/>
                       </a:pPr>
                       <a:r>
-                        <a:rPr lang="en-US" sz="1000" b="0" dirty="0"/>
+                        <a:rPr lang="en-US" sz="1100" b="0" dirty="0"/>
                         <a:t>Moisture Survey System</a:t>
                       </a:r>
                     </a:p>
@@ -21478,7 +22134,7 @@
                     <a:bodyPr/>
                     <a:lstStyle/>
                     <a:p>
-                      <a:endParaRPr lang="en-US" sz="1000" dirty="0"/>
+                      <a:endParaRPr lang="en-US" sz="1100" dirty="0"/>
                     </a:p>
                   </a:txBody>
                   <a:tcPr>
@@ -21529,7 +22185,7 @@
                     <a:lstStyle/>
                     <a:p>
                       <a:r>
-                        <a:rPr lang="en-US" sz="1000" dirty="0"/>
+                        <a:rPr lang="en-US" sz="1100" dirty="0"/>
                         <a:t>Some manufacturers offer contractors discounted thermal surveys through national agreements</a:t>
                       </a:r>
                     </a:p>
@@ -21580,7 +22236,7 @@
                     <a:lstStyle/>
                     <a:p>
                       <a:r>
-                        <a:rPr lang="en-US" sz="1000" dirty="0"/>
+                        <a:rPr lang="en-US" sz="1100" dirty="0"/>
                         <a:t>John T Hull</a:t>
                       </a:r>
                     </a:p>
@@ -21635,6 +22291,328 @@
           </a:graphicData>
         </a:graphic>
       </p:graphicFrame>
+      <p:sp>
+        <p:nvSpPr>
+          <p:cNvPr id="11" name="Legend 11"/>
+          <p:cNvSpPr txBox="1"/>
+          <p:nvPr/>
+        </p:nvSpPr>
+        <p:spPr>
+          <a:xfrm>
+            <a:off x="304800" y="6250000"/>
+            <a:ext cx="1300000" cy="228600"/>
+          </a:xfrm>
+          <a:prstGeom prst="rect">
+            <a:avLst/>
+          </a:prstGeom>
+          <a:noFill/>
+          <a:ln>
+            <a:noFill/>
+          </a:ln>
+        </p:spPr>
+        <p:txBody>
+          <a:bodyPr wrap="none" lIns="0" tIns="0" rIns="0" bIns="0" anchor="ctr"/>
+          <a:lstStyle/>
+          <a:p>
+            <a:r>
+              <a:rPr lang="en-US" sz="1100" b="1">
+                <a:solidFill>
+                  <a:srgbClr val="404040"/>
+                </a:solidFill>
+              </a:rPr>
+              <a:t>Henry's position:</a:t>
+            </a:r>
+          </a:p>
+        </p:txBody>
+      </p:sp>
+      <p:sp>
+        <p:nvSpPr>
+          <p:cNvPr id="12" name="Legend 12"/>
+          <p:cNvSpPr txBox="0"/>
+          <p:nvPr/>
+        </p:nvSpPr>
+        <p:spPr>
+          <a:xfrm>
+            <a:off x="1654800" y="6250000"/>
+            <a:ext cx="228600" cy="228600"/>
+          </a:xfrm>
+          <a:prstGeom prst="rect">
+            <a:avLst/>
+          </a:prstGeom>
+          <a:solidFill>
+            <a:srgbClr val="00B050"/>
+          </a:solidFill>
+          <a:ln w="6350">
+            <a:solidFill>
+              <a:srgbClr val="7F7F7F"/>
+            </a:solidFill>
+          </a:ln>
+        </p:spPr>
+        <p:txBody>
+          <a:bodyPr wrap="none" lIns="0" tIns="0" rIns="0" bIns="0" anchor="ctr"/>
+          <a:lstStyle/>
+          <a:p>
+            <a:r>
+              <a:rPr lang="en-US" sz="1100">
+                <a:solidFill>
+                  <a:srgbClr val="404040"/>
+                </a:solidFill>
+              </a:rPr>
+              <a:t/>
+            </a:r>
+          </a:p>
+        </p:txBody>
+      </p:sp>
+      <p:sp>
+        <p:nvSpPr>
+          <p:cNvPr id="13" name="Legend 13"/>
+          <p:cNvSpPr txBox="1"/>
+          <p:nvPr/>
+        </p:nvSpPr>
+        <p:spPr>
+          <a:xfrm>
+            <a:off x="1954800" y="6250000"/>
+            <a:ext cx="650000" cy="228600"/>
+          </a:xfrm>
+          <a:prstGeom prst="rect">
+            <a:avLst/>
+          </a:prstGeom>
+          <a:noFill/>
+          <a:ln>
+            <a:noFill/>
+          </a:ln>
+        </p:spPr>
+        <p:txBody>
+          <a:bodyPr wrap="none" lIns="0" tIns="0" rIns="0" bIns="0" anchor="ctr"/>
+          <a:lstStyle/>
+          <a:p>
+            <a:r>
+              <a:rPr lang="en-US" sz="1100">
+                <a:solidFill>
+                  <a:srgbClr val="404040"/>
+                </a:solidFill>
+              </a:rPr>
+              <a:t>Strong</a:t>
+            </a:r>
+          </a:p>
+        </p:txBody>
+      </p:sp>
+      <p:sp>
+        <p:nvSpPr>
+          <p:cNvPr id="14" name="Legend 14"/>
+          <p:cNvSpPr txBox="0"/>
+          <p:nvPr/>
+        </p:nvSpPr>
+        <p:spPr>
+          <a:xfrm>
+            <a:off x="2654800" y="6250000"/>
+            <a:ext cx="228600" cy="228600"/>
+          </a:xfrm>
+          <a:prstGeom prst="rect">
+            <a:avLst/>
+          </a:prstGeom>
+          <a:solidFill>
+            <a:srgbClr val="FFFF00"/>
+          </a:solidFill>
+          <a:ln w="6350">
+            <a:solidFill>
+              <a:srgbClr val="7F7F7F"/>
+            </a:solidFill>
+          </a:ln>
+        </p:spPr>
+        <p:txBody>
+          <a:bodyPr wrap="none" lIns="0" tIns="0" rIns="0" bIns="0" anchor="ctr"/>
+          <a:lstStyle/>
+          <a:p>
+            <a:r>
+              <a:rPr lang="en-US" sz="1100">
+                <a:solidFill>
+                  <a:srgbClr val="404040"/>
+                </a:solidFill>
+              </a:rPr>
+              <a:t/>
+            </a:r>
+          </a:p>
+        </p:txBody>
+      </p:sp>
+      <p:sp>
+        <p:nvSpPr>
+          <p:cNvPr id="15" name="Legend 15"/>
+          <p:cNvSpPr txBox="1"/>
+          <p:nvPr/>
+        </p:nvSpPr>
+        <p:spPr>
+          <a:xfrm>
+            <a:off x="2954800" y="6250000"/>
+            <a:ext cx="650000" cy="228600"/>
+          </a:xfrm>
+          <a:prstGeom prst="rect">
+            <a:avLst/>
+          </a:prstGeom>
+          <a:noFill/>
+          <a:ln>
+            <a:noFill/>
+          </a:ln>
+        </p:spPr>
+        <p:txBody>
+          <a:bodyPr wrap="none" lIns="0" tIns="0" rIns="0" bIns="0" anchor="ctr"/>
+          <a:lstStyle/>
+          <a:p>
+            <a:r>
+              <a:rPr lang="en-US" sz="1100">
+                <a:solidFill>
+                  <a:srgbClr val="404040"/>
+                </a:solidFill>
+              </a:rPr>
+              <a:t>Fair</a:t>
+            </a:r>
+          </a:p>
+        </p:txBody>
+      </p:sp>
+      <p:sp>
+        <p:nvSpPr>
+          <p:cNvPr id="16" name="Legend 16"/>
+          <p:cNvSpPr txBox="0"/>
+          <p:nvPr/>
+        </p:nvSpPr>
+        <p:spPr>
+          <a:xfrm>
+            <a:off x="3654800" y="6250000"/>
+            <a:ext cx="228600" cy="228600"/>
+          </a:xfrm>
+          <a:prstGeom prst="rect">
+            <a:avLst/>
+          </a:prstGeom>
+          <a:solidFill>
+            <a:srgbClr val="FFC000"/>
+          </a:solidFill>
+          <a:ln w="6350">
+            <a:solidFill>
+              <a:srgbClr val="7F7F7F"/>
+            </a:solidFill>
+          </a:ln>
+        </p:spPr>
+        <p:txBody>
+          <a:bodyPr wrap="none" lIns="0" tIns="0" rIns="0" bIns="0" anchor="ctr"/>
+          <a:lstStyle/>
+          <a:p>
+            <a:r>
+              <a:rPr lang="en-US" sz="1100">
+                <a:solidFill>
+                  <a:srgbClr val="404040"/>
+                </a:solidFill>
+              </a:rPr>
+              <a:t/>
+            </a:r>
+          </a:p>
+        </p:txBody>
+      </p:sp>
+      <p:sp>
+        <p:nvSpPr>
+          <p:cNvPr id="17" name="Legend 17"/>
+          <p:cNvSpPr txBox="1"/>
+          <p:nvPr/>
+        </p:nvSpPr>
+        <p:spPr>
+          <a:xfrm>
+            <a:off x="3954800" y="6250000"/>
+            <a:ext cx="650000" cy="228600"/>
+          </a:xfrm>
+          <a:prstGeom prst="rect">
+            <a:avLst/>
+          </a:prstGeom>
+          <a:noFill/>
+          <a:ln>
+            <a:noFill/>
+          </a:ln>
+        </p:spPr>
+        <p:txBody>
+          <a:bodyPr wrap="none" lIns="0" tIns="0" rIns="0" bIns="0" anchor="ctr"/>
+          <a:lstStyle/>
+          <a:p>
+            <a:r>
+              <a:rPr lang="en-US" sz="1100">
+                <a:solidFill>
+                  <a:srgbClr val="404040"/>
+                </a:solidFill>
+              </a:rPr>
+              <a:t>Weak</a:t>
+            </a:r>
+          </a:p>
+        </p:txBody>
+      </p:sp>
+      <p:sp>
+        <p:nvSpPr>
+          <p:cNvPr id="18" name="Legend 18"/>
+          <p:cNvSpPr txBox="0"/>
+          <p:nvPr/>
+        </p:nvSpPr>
+        <p:spPr>
+          <a:xfrm>
+            <a:off x="4654800" y="6250000"/>
+            <a:ext cx="228600" cy="228600"/>
+          </a:xfrm>
+          <a:prstGeom prst="rect">
+            <a:avLst/>
+          </a:prstGeom>
+          <a:solidFill>
+            <a:srgbClr val="FF9999"/>
+          </a:solidFill>
+          <a:ln w="6350">
+            <a:solidFill>
+              <a:srgbClr val="7F7F7F"/>
+            </a:solidFill>
+          </a:ln>
+        </p:spPr>
+        <p:txBody>
+          <a:bodyPr wrap="none" lIns="0" tIns="0" rIns="0" bIns="0" anchor="ctr"/>
+          <a:lstStyle/>
+          <a:p>
+            <a:r>
+              <a:rPr lang="en-US" sz="1100">
+                <a:solidFill>
+                  <a:srgbClr val="404040"/>
+                </a:solidFill>
+              </a:rPr>
+              <a:t/>
+            </a:r>
+          </a:p>
+        </p:txBody>
+      </p:sp>
+      <p:sp>
+        <p:nvSpPr>
+          <p:cNvPr id="19" name="Legend 19"/>
+          <p:cNvSpPr txBox="1"/>
+          <p:nvPr/>
+        </p:nvSpPr>
+        <p:spPr>
+          <a:xfrm>
+            <a:off x="4954800" y="6250000"/>
+            <a:ext cx="650000" cy="228600"/>
+          </a:xfrm>
+          <a:prstGeom prst="rect">
+            <a:avLst/>
+          </a:prstGeom>
+          <a:noFill/>
+          <a:ln>
+            <a:noFill/>
+          </a:ln>
+        </p:spPr>
+        <p:txBody>
+          <a:bodyPr wrap="none" lIns="0" tIns="0" rIns="0" bIns="0" anchor="ctr"/>
+          <a:lstStyle/>
+          <a:p>
+            <a:r>
+              <a:rPr lang="en-US" sz="1100">
+                <a:solidFill>
+                  <a:srgbClr val="404040"/>
+                </a:solidFill>
+              </a:rPr>
+              <a:t>Poor</a:t>
+            </a:r>
+          </a:p>
+        </p:txBody>
+      </p:sp>
     </p:spTree>
     <p:extLst>
       <p:ext uri="{BB962C8B-B14F-4D97-AF65-F5344CB8AC3E}">

</xml_diff>